<commit_message>
Move the design doc draft to Fri, Oct 16 and give it a Canvas assignment
The draft moves one more day, off Thursday, for flexibility; it touches
neither Monday's session nor the CP5 revision window (still Wed, Oct 21).
The date lives in DESIGN_DRAFT_DUE / DESIGN_DRAFT_DUE_DAY; outlines 10-12,
the Session 11/12 student pages, the course summary, and the Session 11/12
deck scripts are swept to match.

Add cp5-draft, a completion-graded team upload with its own handout
(CP5-Draft-Turn-In) linking the full CP5 assignment. It is the baseline the
CP5 "Readability & revision" criterion measures against. Listed under
Session 12 in the Phase 3 module and on the Session 12 page's Due list;
references to an "LMS pointer to the repo" now point at it.

Rebuild both Session 12 decks: the wrap slide carries the Friday date and
the commit-and-upload instruction. The Session 11 deck is not rebuilt.

Co-Authored-By: Claude Opus 5.5 (1M context) <noreply@anthropic.com>
</commit_message>
<xml_diff>
--- a/canvas_material/lectures/powerpoint/Session12-ArchitectureWorkshop-inclass.pptx
+++ b/canvas_material/lectures/powerpoint/Session12-ArchitectureWorkshop-inclass.pptx
@@ -1844,7 +1844,7 @@
           <a:p>
             <a:r>
               <a:rPr lang="en-US" dirty="0"/>
-              <a:t>Two minutes to close. Say why the draft is due tomorrow rather than tonight: the boards are the work, this is transcription, and a night in between buys a better document while keeping it off the same evening as the team charter. Then the loop — draft, review, revise — named out loud, because it is the same shape as the proposal, and revision is graded on the Design Document exactly as it was on the Written Proposal. If the room looks daunted by Oct 21, remind them the hard eighty percent is already on their phones.</a:t>
+              <a:t>Two minutes to close. Say why the draft is due Friday rather than tonight: the boards are the work, this is transcription, and a couple of days in between buys a better document while keeping it off the same evening as the team charter. Then the loop — draft, review, revise — named out loud, because it is the same shape as the proposal, and revision is graded on the Design Document exactly as it was on the Written Proposal. If the room looks daunted by Oct 21, remind them the hard eighty percent is already on their phones.</a:t>
             </a:r>
             <a:endParaRPr lang="en-US" dirty="0"/>
           </a:p>
@@ -2108,7 +2108,7 @@
           <a:p>
             <a:r>
               <a:rPr lang="en-US" dirty="0"/>
-              <a:t>One minute. Walk the five rounds and point at the template column — that mapping is the reason the draft is due tomorrow rather than next week. Do not explain the rounds here; each has its own pair of slides. The line at the bottom is the promise worth making explicitly, because students hear whiteboard workshop and assume a second night of writing is coming.</a:t>
+              <a:t>One minute. Walk the five rounds and point at the template column — that mapping is the reason the draft is due Friday rather than next week. Do not explain the rounds here; each has its own pair of slides. The line at the bottom is the promise worth making explicitly, because students hear whiteboard workshop and assume a second night of writing is coming.</a:t>
             </a:r>
             <a:endParaRPr lang="en-US" dirty="0"/>
           </a:p>
@@ -14591,7 +14591,7 @@
                 <a:ea typeface="Calibri" pitchFamily="34" charset="-122"/>
                 <a:cs typeface="Calibri" pitchFamily="34" charset="-120"/>
               </a:rPr>
-              <a:t>A photo of a whiteboard is a legitimate diagram for the draft. The boards are the work — tonight is transcription.</a:t>
+              <a:t>A photo of a whiteboard is a legitimate diagram for the draft. The boards are the work — what follows is transcription.</a:t>
             </a:r>
             <a:endParaRPr lang="en-US" sz="1700" dirty="0"/>
           </a:p>
@@ -14914,7 +14914,7 @@
                 <a:ea typeface="Calibri" pitchFamily="34" charset="-122"/>
                 <a:cs typeface="Calibri" pitchFamily="34" charset="-120"/>
               </a:rPr>
-              <a:t>Design Document draft — end of day tomorrow, Thu, Oct 15
+              <a:t>Design Document draft — end of day Fri, Oct 16
 </a:t>
             </a:r>
             <a:pPr indent="0" marL="0">
@@ -14932,7 +14932,7 @@
                 <a:ea typeface="Calibri" pitchFamily="34" charset="-122"/>
                 <a:cs typeface="Calibri" pitchFamily="34" charset="-120"/>
               </a:rPr>
-              <a:t>Photographed diagrams + skeleton prose + your two argued decisions. That's a complete draft.</a:t>
+              <a:t>Photographed diagrams + skeleton prose + your two argued decisions. Commit it as docs/design.md and upload a copy to Canvas.</a:t>
             </a:r>
             <a:endParaRPr lang="en-US" sz="1650" dirty="0"/>
           </a:p>
@@ -16974,7 +16974,7 @@
                 <a:ea typeface="Cambria" pitchFamily="34" charset="-122"/>
                 <a:cs typeface="Cambria" pitchFamily="34" charset="-120"/>
               </a:rPr>
-              <a:t>Five rounds — and the draft writes itself tonight</a:t>
+              <a:t>Five rounds — and the draft is mostly written here</a:t>
             </a:r>
             <a:endParaRPr lang="en-US" sz="3100" dirty="0"/>
           </a:p>
@@ -17992,7 +17992,7 @@
                 <a:ea typeface="Calibri" pitchFamily="34" charset="-122"/>
                 <a:cs typeface="Calibri" pitchFamily="34" charset="-120"/>
               </a:rPr>
-              <a:t>Each round fills a numbered section of the template, in order. Tonight is transcription, not composition.</a:t>
+              <a:t>Each round fills a numbered section of the template, in order. What follows is transcription, not composition.</a:t>
             </a:r>
             <a:endParaRPr lang="en-US" sz="1550" dirty="0"/>
           </a:p>

</xml_diff>